<commit_message>
Update conference survey: aaai icml
Per conference: venue.json (deadlines, past editions, format, features,
trends, matching fields, award list), award-paper deck (pptx/pdf with a
details slide per paper), spec.json, figures and README; conferences.json
and the generated branch README.

Co-Authored-By: Claude Opus 5.5 <noreply@anthropic.com>
Claude-Session: https://claude.ai/code/session_01XCo1fEaxRp1ZKVxVZ14mEu
</commit_message>
<xml_diff>
--- a/aaai/aaai.pptx
+++ b/aaai/aaai.pptx
@@ -9849,7 +9849,7 @@
                 <a:ea typeface="Meiryo" pitchFamily="34" charset="-122"/>
                 <a:cs typeface="Meiryo" pitchFamily="34" charset="-120"/>
               </a:rPr>
-              <a:t>学会調査 › AAAI：受賞・注目論文 ｜ AAAI-26 Outstanding Paper Award（Main Technical Track）</a:t>
+              <a:t>学会調査 › AAAI：受賞・注目論文 ｜ AAAI-26 Outstanding Paper Award</a:t>
             </a:r>
             <a:endParaRPr lang="en-US" sz="1100" dirty="0"/>
           </a:p>
@@ -10289,12 +10289,12 @@
           <a:p>
             <a:pPr indent="0" marL="0">
               <a:lnSpc>
-                <a:spcPts val="1350"/>
-              </a:lnSpc>
-              <a:buNone/>
-            </a:pPr>
-            <a:r>
-              <a:rPr lang="en-US" sz="1000" b="1" dirty="0">
+                <a:spcPts val="1400"/>
+              </a:lnSpc>
+              <a:buNone/>
+            </a:pPr>
+            <a:r>
+              <a:rPr lang="en-US" sz="1050" b="1" dirty="0">
                 <a:solidFill>
                   <a:srgbClr val="1E2433"/>
                 </a:solidFill>
@@ -10306,12 +10306,12 @@
             </a:r>
             <a:pPr indent="0" marL="0">
               <a:lnSpc>
-                <a:spcPts val="1350"/>
-              </a:lnSpc>
-              <a:buNone/>
-            </a:pPr>
-            <a:r>
-              <a:rPr lang="en-US" sz="1000" dirty="0">
+                <a:spcPts val="1400"/>
+              </a:lnSpc>
+              <a:buNone/>
+            </a:pPr>
+            <a:r>
+              <a:rPr lang="en-US" sz="1050" dirty="0">
                 <a:solidFill>
                   <a:srgbClr val="1E2433"/>
                 </a:solidFill>
@@ -10326,12 +10326,12 @@
           <a:p>
             <a:pPr indent="0" marL="0">
               <a:lnSpc>
-                <a:spcPts val="1350"/>
-              </a:lnSpc>
-              <a:buNone/>
-            </a:pPr>
-            <a:r>
-              <a:rPr lang="en-US" sz="1000" b="1" dirty="0">
+                <a:spcPts val="1400"/>
+              </a:lnSpc>
+              <a:buNone/>
+            </a:pPr>
+            <a:r>
+              <a:rPr lang="en-US" sz="1050" b="1" dirty="0">
                 <a:solidFill>
                   <a:srgbClr val="1E2433"/>
                 </a:solidFill>
@@ -10343,12 +10343,12 @@
             </a:r>
             <a:pPr indent="0" marL="0">
               <a:lnSpc>
-                <a:spcPts val="1350"/>
-              </a:lnSpc>
-              <a:buNone/>
-            </a:pPr>
-            <a:r>
-              <a:rPr lang="en-US" sz="1000" u="sng" dirty="0">
+                <a:spcPts val="1400"/>
+              </a:lnSpc>
+              <a:buNone/>
+            </a:pPr>
+            <a:r>
+              <a:rPr lang="en-US" sz="1050" u="sng" dirty="0">
                 <a:solidFill>
                   <a:srgbClr val="1E2433"/>
                 </a:solidFill>
@@ -10370,12 +10370,12 @@
           <a:p>
             <a:pPr indent="0" marL="0">
               <a:lnSpc>
-                <a:spcPts val="1350"/>
-              </a:lnSpc>
-              <a:buNone/>
-            </a:pPr>
-            <a:r>
-              <a:rPr lang="en-US" sz="1000" b="1" dirty="0">
+                <a:spcPts val="1400"/>
+              </a:lnSpc>
+              <a:buNone/>
+            </a:pPr>
+            <a:r>
+              <a:rPr lang="en-US" sz="1050" b="1" dirty="0">
                 <a:solidFill>
                   <a:srgbClr val="1E2433"/>
                 </a:solidFill>
@@ -10387,32 +10387,32 @@
             </a:r>
             <a:pPr indent="0" marL="0">
               <a:lnSpc>
-                <a:spcPts val="1350"/>
-              </a:lnSpc>
-              <a:buNone/>
-            </a:pPr>
-            <a:r>
-              <a:rPr lang="en-US" sz="1000" dirty="0">
-                <a:solidFill>
-                  <a:srgbClr val="1E2433"/>
-                </a:solidFill>
-                <a:latin typeface="Meiryo" pitchFamily="34" charset="0"/>
-                <a:ea typeface="Meiryo" pitchFamily="34" charset="-122"/>
-                <a:cs typeface="Meiryo" pitchFamily="34" charset="-120"/>
-              </a:rPr>
-              <a:t>AAAI-26 Outstanding Paper Award（Main Technical Track）</a:t>
+                <a:spcPts val="1400"/>
+              </a:lnSpc>
+              <a:buNone/>
+            </a:pPr>
+            <a:r>
+              <a:rPr lang="en-US" sz="1050" dirty="0">
+                <a:solidFill>
+                  <a:srgbClr val="1E2433"/>
+                </a:solidFill>
+                <a:latin typeface="Meiryo" pitchFamily="34" charset="0"/>
+                <a:ea typeface="Meiryo" pitchFamily="34" charset="-122"/>
+                <a:cs typeface="Meiryo" pitchFamily="34" charset="-120"/>
+              </a:rPr>
+              <a:t>AAAI-26 Outstanding Paper Award</a:t>
             </a:r>
             <a:endParaRPr lang="en-US" sz="1050" dirty="0"/>
           </a:p>
           <a:p>
             <a:pPr indent="0" marL="0">
               <a:lnSpc>
-                <a:spcPts val="1350"/>
-              </a:lnSpc>
-              <a:buNone/>
-            </a:pPr>
-            <a:r>
-              <a:rPr lang="en-US" sz="1000" b="1" dirty="0">
+                <a:spcPts val="1400"/>
+              </a:lnSpc>
+              <a:buNone/>
+            </a:pPr>
+            <a:r>
+              <a:rPr lang="en-US" sz="1050" b="1" dirty="0">
                 <a:solidFill>
                   <a:srgbClr val="1E2433"/>
                 </a:solidFill>
@@ -10424,12 +10424,12 @@
             </a:r>
             <a:pPr indent="0" marL="0">
               <a:lnSpc>
-                <a:spcPts val="1350"/>
-              </a:lnSpc>
-              <a:buNone/>
-            </a:pPr>
-            <a:r>
-              <a:rPr lang="en-US" sz="1000" dirty="0">
+                <a:spcPts val="1400"/>
+              </a:lnSpc>
+              <a:buNone/>
+            </a:pPr>
+            <a:r>
+              <a:rPr lang="en-US" sz="1050" dirty="0">
                 <a:solidFill>
                   <a:srgbClr val="1E2433"/>
                 </a:solidFill>
@@ -10444,12 +10444,12 @@
           <a:p>
             <a:pPr indent="0" marL="0">
               <a:lnSpc>
-                <a:spcPts val="1350"/>
-              </a:lnSpc>
-              <a:buNone/>
-            </a:pPr>
-            <a:r>
-              <a:rPr lang="en-US" sz="1000" b="1" dirty="0">
+                <a:spcPts val="1400"/>
+              </a:lnSpc>
+              <a:buNone/>
+            </a:pPr>
+            <a:r>
+              <a:rPr lang="en-US" sz="1050" b="1" dirty="0">
                 <a:solidFill>
                   <a:srgbClr val="1E2433"/>
                 </a:solidFill>
@@ -10461,12 +10461,12 @@
             </a:r>
             <a:pPr indent="0" marL="0">
               <a:lnSpc>
-                <a:spcPts val="1350"/>
-              </a:lnSpc>
-              <a:buNone/>
-            </a:pPr>
-            <a:r>
-              <a:rPr lang="en-US" sz="1000" dirty="0">
+                <a:spcPts val="1400"/>
+              </a:lnSpc>
+              <a:buNone/>
+            </a:pPr>
+            <a:r>
+              <a:rPr lang="en-US" sz="1050" dirty="0">
                 <a:solidFill>
                   <a:srgbClr val="1E2433"/>
                 </a:solidFill>
@@ -10692,7 +10692,7 @@
                 <a:ea typeface="Meiryo" pitchFamily="34" charset="-122"/>
                 <a:cs typeface="Meiryo" pitchFamily="34" charset="-120"/>
               </a:rPr>
-              <a:t>学会調査 › AAAI：受賞・注目論文 ｜ AAAI-26 Outstanding Paper Award（Main Technical Track） ｜ 詳細・評価ポイント</a:t>
+              <a:t>学会調査 › AAAI：受賞・注目論文 ｜ AAAI-26 Outstanding Paper Award ｜ 詳細・評価ポイント</a:t>
             </a:r>
             <a:endParaRPr lang="en-US" sz="1100" dirty="0"/>
           </a:p>
@@ -10945,7 +10945,7 @@
                 <a:ea typeface="Meiryo" pitchFamily="34" charset="-122"/>
                 <a:cs typeface="Meiryo" pitchFamily="34" charset="-120"/>
               </a:rPr>
-              <a:t>AAAI-26 Outstanding Paper Award（Main Technical Track）</a:t>
+              <a:t>AAAI-26 Outstanding Paper Award</a:t>
             </a:r>
             <a:endParaRPr lang="en-US" sz="1200" dirty="0"/>
           </a:p>
@@ -18807,7 +18807,7 @@
                 <a:ea typeface="Meiryo" pitchFamily="34" charset="-122"/>
                 <a:cs typeface="Meiryo" pitchFamily="34" charset="-120"/>
               </a:rPr>
-              <a:t>Nikhil Chandak, Shashwat Goel, Dominik Peters（MPI-IS・CNRS LAMSADE（arXiv v2 の所属））｜ AAAI 2024</a:t>
+              <a:t>Nikhil Chandak, Shashwat Goel, Dominik Peters（MPI-IS・CNRS LAMSADE）｜ AAAI 2024</a:t>
             </a:r>
             <a:endParaRPr lang="en-US" sz="1200" dirty="0"/>
           </a:p>
@@ -19650,7 +19650,7 @@
                 <a:ea typeface="Meiryo" pitchFamily="34" charset="-122"/>
                 <a:cs typeface="Meiryo" pitchFamily="34" charset="-120"/>
               </a:rPr>
-              <a:t>Nikhil Chandak, Shashwat Goel, Dominik Peters（MPI-IS・CNRS LAMSADE（arXiv v2 の所属））｜ AAAI 2024</a:t>
+              <a:t>Nikhil Chandak, Shashwat Goel, Dominik Peters（MPI-IS・CNRS LAMSADE）｜ AAAI 2024</a:t>
             </a:r>
             <a:endParaRPr lang="en-US" sz="1200" dirty="0"/>
           </a:p>

</xml_diff>